<commit_message>
docs: rescope the parameter-plane deck to scale-out only
Drop scale-up, north-south, and commercial terms. Rebuild the slides
as a single-accent specification sheet, and add the OpenAI/Microsoft
MRC papers as the worked example of a customer transport on NVIDIA silicon.

Co-authored-by: 69515164-rgb <69515164-rgb@users.noreply.github.com>
</commit_message>
<xml_diff>
--- a/docs/nvidia-param-plane.pptx
+++ b/docs/nvidia-param-plane.pptx
@@ -21,9 +21,6 @@
     <p:sldId id="269" r:id="rId20"/>
     <p:sldId id="270" r:id="rId21"/>
     <p:sldId id="271" r:id="rId22"/>
-    <p:sldId id="272" r:id="rId23"/>
-    <p:sldId id="273" r:id="rId24"/>
-    <p:sldId id="274" r:id="rId25"/>
   </p:sldIdLst>
   <p:sldSz cx="12191999" cy="6858000" type="screen4x3"/>
   <p:notesSz cx="6858000" cy="9144000"/>
@@ -3403,132 +3400,6 @@
       <p:pic>
         <p:nvPicPr>
           <p:cNvPr id="2" name="Picture 1" descr="16.png"/>
-          <p:cNvPicPr>
-            <a:picLocks noChangeAspect="1"/>
-          </p:cNvPicPr>
-          <p:nvPr/>
-        </p:nvPicPr>
-        <p:blipFill>
-          <a:blip r:embed="rId2"/>
-          <a:stretch>
-            <a:fillRect/>
-          </a:stretch>
-        </p:blipFill>
-        <p:spPr>
-          <a:xfrm>
-            <a:off x="0" y="0"/>
-            <a:ext cx="12191999" cy="6858000"/>
-          </a:xfrm>
-          <a:prstGeom prst="rect">
-            <a:avLst/>
-          </a:prstGeom>
-        </p:spPr>
-      </p:pic>
-    </p:spTree>
-  </p:cSld>
-  <p:clrMapOvr>
-    <a:masterClrMapping/>
-  </p:clrMapOvr>
-</p:sld>
-</file>
-
-<file path=ppt/slides/slide17.xml><?xml version="1.0" encoding="utf-8"?>
-<p:sld xmlns:a="http://schemas.openxmlformats.org/drawingml/2006/main" xmlns:p="http://schemas.openxmlformats.org/presentationml/2006/main" xmlns:r="http://schemas.openxmlformats.org/officeDocument/2006/relationships">
-  <p:cSld>
-    <p:spTree>
-      <p:nvGrpSpPr>
-        <p:cNvPr id="1" name=""/>
-        <p:cNvGrpSpPr/>
-        <p:nvPr/>
-      </p:nvGrpSpPr>
-      <p:grpSpPr/>
-      <p:pic>
-        <p:nvPicPr>
-          <p:cNvPr id="2" name="Picture 1" descr="17.png"/>
-          <p:cNvPicPr>
-            <a:picLocks noChangeAspect="1"/>
-          </p:cNvPicPr>
-          <p:nvPr/>
-        </p:nvPicPr>
-        <p:blipFill>
-          <a:blip r:embed="rId2"/>
-          <a:stretch>
-            <a:fillRect/>
-          </a:stretch>
-        </p:blipFill>
-        <p:spPr>
-          <a:xfrm>
-            <a:off x="0" y="0"/>
-            <a:ext cx="12191999" cy="6858000"/>
-          </a:xfrm>
-          <a:prstGeom prst="rect">
-            <a:avLst/>
-          </a:prstGeom>
-        </p:spPr>
-      </p:pic>
-    </p:spTree>
-  </p:cSld>
-  <p:clrMapOvr>
-    <a:masterClrMapping/>
-  </p:clrMapOvr>
-</p:sld>
-</file>
-
-<file path=ppt/slides/slide18.xml><?xml version="1.0" encoding="utf-8"?>
-<p:sld xmlns:a="http://schemas.openxmlformats.org/drawingml/2006/main" xmlns:p="http://schemas.openxmlformats.org/presentationml/2006/main" xmlns:r="http://schemas.openxmlformats.org/officeDocument/2006/relationships">
-  <p:cSld>
-    <p:spTree>
-      <p:nvGrpSpPr>
-        <p:cNvPr id="1" name=""/>
-        <p:cNvGrpSpPr/>
-        <p:nvPr/>
-      </p:nvGrpSpPr>
-      <p:grpSpPr/>
-      <p:pic>
-        <p:nvPicPr>
-          <p:cNvPr id="2" name="Picture 1" descr="18.png"/>
-          <p:cNvPicPr>
-            <a:picLocks noChangeAspect="1"/>
-          </p:cNvPicPr>
-          <p:nvPr/>
-        </p:nvPicPr>
-        <p:blipFill>
-          <a:blip r:embed="rId2"/>
-          <a:stretch>
-            <a:fillRect/>
-          </a:stretch>
-        </p:blipFill>
-        <p:spPr>
-          <a:xfrm>
-            <a:off x="0" y="0"/>
-            <a:ext cx="12191999" cy="6858000"/>
-          </a:xfrm>
-          <a:prstGeom prst="rect">
-            <a:avLst/>
-          </a:prstGeom>
-        </p:spPr>
-      </p:pic>
-    </p:spTree>
-  </p:cSld>
-  <p:clrMapOvr>
-    <a:masterClrMapping/>
-  </p:clrMapOvr>
-</p:sld>
-</file>
-
-<file path=ppt/slides/slide19.xml><?xml version="1.0" encoding="utf-8"?>
-<p:sld xmlns:a="http://schemas.openxmlformats.org/drawingml/2006/main" xmlns:p="http://schemas.openxmlformats.org/presentationml/2006/main" xmlns:r="http://schemas.openxmlformats.org/officeDocument/2006/relationships">
-  <p:cSld>
-    <p:spTree>
-      <p:nvGrpSpPr>
-        <p:cNvPr id="1" name=""/>
-        <p:cNvGrpSpPr/>
-        <p:nvPr/>
-      </p:nvGrpSpPr>
-      <p:grpSpPr/>
-      <p:pic>
-        <p:nvPicPr>
-          <p:cNvPr id="2" name="Picture 1" descr="19.png"/>
           <p:cNvPicPr>
             <a:picLocks noChangeAspect="1"/>
           </p:cNvPicPr>

</xml_diff>